<commit_message>
Fix quarterly-review template overflow
Use LAYOUT_WIDE (13.33x7.5) instead of LAYOUT_16x9, which in pptxgenjs is
10x5.625 — the full-width gold/navy bars and the 4th KPI card were laid out for
a 13.33-wide canvas and ran off the right edge. Also add shrink-to-fit and
middle valign to the heading and KPI label/value boxes so long figures and
titles scale to fit instead of spilling, and drop the KPI value font 30->28.
Regenerate the committed .pptx.
</commit_message>
<xml_diff>
--- a/backend/templates/quarterly-review.pptx
+++ b/backend/templates/quarterly-review.pptx
@@ -11,8 +11,8 @@
   <p:notesMasterIdLst>
     <p:notesMasterId r:id="rId4"/>
   </p:notesMasterIdLst>
-  <p:sldSz cx="9144000" cy="5143500"/>
-  <p:notesSz cx="5143500" cy="9144000"/>
+  <p:sldSz cx="12192000" cy="6858000"/>
+  <p:notesSz cx="6858000" cy="12192000"/>
   <p:defaultTextStyle>
     <a:lvl1pPr marL="0" algn="l" defTabSz="914400" rtl="0" eaLnBrk="1" latinLnBrk="0" hangingPunct="1">
       <a:defRPr sz="1800" kern="1200">
@@ -1201,8 +1201,8 @@
         </p:nvSpPr>
         <p:spPr>
           <a:xfrm>
-            <a:off x="548640" y="182880"/>
-            <a:ext cx="10972800" cy="640080"/>
+            <a:off x="548640" y="0"/>
+            <a:ext cx="11064240" cy="1005840"/>
           </a:xfrm>
           <a:prstGeom prst="rect">
             <a:avLst/>
@@ -1211,7 +1211,9 @@
           <a:ln/>
         </p:spPr>
         <p:txBody>
-          <a:bodyPr wrap="square" rtlCol="0" anchor="ctr"/>
+          <a:bodyPr wrap="square" rtlCol="0" anchor="ctr">
+            <a:normAutofit/>
+          </a:bodyPr>
           <a:lstStyle/>
           <a:p>
             <a:pPr algn="l" indent="0" marL="0">
@@ -1277,7 +1279,9 @@
           <a:ln/>
         </p:spPr>
         <p:txBody>
-          <a:bodyPr wrap="square" rtlCol="0" anchor="ctr"/>
+          <a:bodyPr wrap="square" rtlCol="0" anchor="ctr">
+            <a:normAutofit/>
+          </a:bodyPr>
           <a:lstStyle/>
           <a:p>
             <a:pPr algn="ctr" indent="0" marL="0">
@@ -1316,14 +1320,16 @@
           <a:ln/>
         </p:spPr>
         <p:txBody>
-          <a:bodyPr wrap="square" rtlCol="0" anchor="ctr"/>
+          <a:bodyPr wrap="square" rtlCol="0" anchor="ctr">
+            <a:normAutofit/>
+          </a:bodyPr>
           <a:lstStyle/>
           <a:p>
             <a:pPr algn="ctr" indent="0" marL="0">
               <a:buNone/>
             </a:pPr>
             <a:r>
-              <a:rPr lang="en-US" sz="3000" b="1" dirty="0">
+              <a:rPr lang="en-US" sz="2800" b="1" dirty="0">
                 <a:solidFill>
                   <a:srgbClr val="1F3864"/>
                 </a:solidFill>
@@ -1333,7 +1339,7 @@
               </a:rPr>
               <a:t>—</a:t>
             </a:r>
-            <a:endParaRPr lang="en-US" sz="3000" dirty="0"/>
+            <a:endParaRPr lang="en-US" sz="2800" dirty="0"/>
           </a:p>
         </p:txBody>
       </p:sp>
@@ -1382,7 +1388,9 @@
           <a:ln/>
         </p:spPr>
         <p:txBody>
-          <a:bodyPr wrap="square" rtlCol="0" anchor="ctr"/>
+          <a:bodyPr wrap="square" rtlCol="0" anchor="ctr">
+            <a:normAutofit/>
+          </a:bodyPr>
           <a:lstStyle/>
           <a:p>
             <a:pPr algn="ctr" indent="0" marL="0">
@@ -1421,14 +1429,16 @@
           <a:ln/>
         </p:spPr>
         <p:txBody>
-          <a:bodyPr wrap="square" rtlCol="0" anchor="ctr"/>
+          <a:bodyPr wrap="square" rtlCol="0" anchor="ctr">
+            <a:normAutofit/>
+          </a:bodyPr>
           <a:lstStyle/>
           <a:p>
             <a:pPr algn="ctr" indent="0" marL="0">
               <a:buNone/>
             </a:pPr>
             <a:r>
-              <a:rPr lang="en-US" sz="3000" b="1" dirty="0">
+              <a:rPr lang="en-US" sz="2800" b="1" dirty="0">
                 <a:solidFill>
                   <a:srgbClr val="1F3864"/>
                 </a:solidFill>
@@ -1438,7 +1448,7 @@
               </a:rPr>
               <a:t>—</a:t>
             </a:r>
-            <a:endParaRPr lang="en-US" sz="3000" dirty="0"/>
+            <a:endParaRPr lang="en-US" sz="2800" dirty="0"/>
           </a:p>
         </p:txBody>
       </p:sp>
@@ -1487,7 +1497,9 @@
           <a:ln/>
         </p:spPr>
         <p:txBody>
-          <a:bodyPr wrap="square" rtlCol="0" anchor="ctr"/>
+          <a:bodyPr wrap="square" rtlCol="0" anchor="ctr">
+            <a:normAutofit/>
+          </a:bodyPr>
           <a:lstStyle/>
           <a:p>
             <a:pPr algn="ctr" indent="0" marL="0">
@@ -1526,14 +1538,16 @@
           <a:ln/>
         </p:spPr>
         <p:txBody>
-          <a:bodyPr wrap="square" rtlCol="0" anchor="ctr"/>
+          <a:bodyPr wrap="square" rtlCol="0" anchor="ctr">
+            <a:normAutofit/>
+          </a:bodyPr>
           <a:lstStyle/>
           <a:p>
             <a:pPr algn="ctr" indent="0" marL="0">
               <a:buNone/>
             </a:pPr>
             <a:r>
-              <a:rPr lang="en-US" sz="3000" b="1" dirty="0">
+              <a:rPr lang="en-US" sz="2800" b="1" dirty="0">
                 <a:solidFill>
                   <a:srgbClr val="1F3864"/>
                 </a:solidFill>
@@ -1543,7 +1557,7 @@
               </a:rPr>
               <a:t>—</a:t>
             </a:r>
-            <a:endParaRPr lang="en-US" sz="3000" dirty="0"/>
+            <a:endParaRPr lang="en-US" sz="2800" dirty="0"/>
           </a:p>
         </p:txBody>
       </p:sp>
@@ -1592,7 +1606,9 @@
           <a:ln/>
         </p:spPr>
         <p:txBody>
-          <a:bodyPr wrap="square" rtlCol="0" anchor="ctr"/>
+          <a:bodyPr wrap="square" rtlCol="0" anchor="ctr">
+            <a:normAutofit/>
+          </a:bodyPr>
           <a:lstStyle/>
           <a:p>
             <a:pPr algn="ctr" indent="0" marL="0">
@@ -1631,14 +1647,16 @@
           <a:ln/>
         </p:spPr>
         <p:txBody>
-          <a:bodyPr wrap="square" rtlCol="0" anchor="ctr"/>
+          <a:bodyPr wrap="square" rtlCol="0" anchor="ctr">
+            <a:normAutofit/>
+          </a:bodyPr>
           <a:lstStyle/>
           <a:p>
             <a:pPr algn="ctr" indent="0" marL="0">
               <a:buNone/>
             </a:pPr>
             <a:r>
-              <a:rPr lang="en-US" sz="3000" b="1" dirty="0">
+              <a:rPr lang="en-US" sz="2800" b="1" dirty="0">
                 <a:solidFill>
                   <a:srgbClr val="1F3864"/>
                 </a:solidFill>
@@ -1648,7 +1666,7 @@
               </a:rPr>
               <a:t>—</a:t>
             </a:r>
-            <a:endParaRPr lang="en-US" sz="3000" dirty="0"/>
+            <a:endParaRPr lang="en-US" sz="2800" dirty="0"/>
           </a:p>
         </p:txBody>
       </p:sp>

</xml_diff>